<commit_message>
fix(slides): fix ch03 footer attribution + add generate_course_slides.py
- Fix FOOTER constant in generate_ch03_slides.py (was "Picking a Frontier
  Model · Koenig AI Academy", now "academy.kspl.tech | Koenig AI Academy")
- Add generic generate_course_slides.py for ch01/ch02/ch04 regen from MD
- Regenerate ch03-slides.pptx with corrected footer (11 slides, all G0)

Part of KOEA-1352 — G0-blocked slide regen

Co-Authored-By: Paperclip <noreply@paperclip.ing>
</commit_message>
<xml_diff>
--- a/vault/courses/picking-a-frontier-model-2026-q2/ch03-slides.pptx
+++ b/vault/courses/picking-a-frontier-model-2026-q2/ch03-slides.pptx
@@ -3614,7 +3614,7 @@
                   <a:srgbClr val="A1A1AA"/>
                 </a:solidFill>
               </a:rPr>
-              <a:t>Picking a Frontier Model — Q2 2026  ·  Koenig AI Academy</a:t>
+              <a:t>academy.kspl.tech | Koenig AI Academy</a:t>
             </a:r>
           </a:p>
         </p:txBody>
@@ -4119,7 +4119,7 @@
                   <a:srgbClr val="A1A1AA"/>
                 </a:solidFill>
               </a:rPr>
-              <a:t>Picking a Frontier Model — Q2 2026  ·  Koenig AI Academy</a:t>
+              <a:t>academy.kspl.tech | Koenig AI Academy</a:t>
             </a:r>
           </a:p>
         </p:txBody>
@@ -4494,7 +4494,7 @@
                   <a:srgbClr val="A1A1AA"/>
                 </a:solidFill>
               </a:rPr>
-              <a:t>Picking a Frontier Model — Q2 2026  ·  Koenig AI Academy</a:t>
+              <a:t>academy.kspl.tech | Koenig AI Academy</a:t>
             </a:r>
           </a:p>
         </p:txBody>
@@ -5456,7 +5456,7 @@
                   <a:srgbClr val="A1A1AA"/>
                 </a:solidFill>
               </a:rPr>
-              <a:t>Picking a Frontier Model — Q2 2026  ·  Koenig AI Academy</a:t>
+              <a:t>academy.kspl.tech | Koenig AI Academy</a:t>
             </a:r>
           </a:p>
         </p:txBody>
@@ -5834,7 +5834,7 @@
                   <a:srgbClr val="A1A1AA"/>
                 </a:solidFill>
               </a:rPr>
-              <a:t>Picking a Frontier Model — Q2 2026  ·  Koenig AI Academy</a:t>
+              <a:t>academy.kspl.tech | Koenig AI Academy</a:t>
             </a:r>
           </a:p>
         </p:txBody>
@@ -6413,7 +6413,7 @@
                   <a:srgbClr val="A1A1AA"/>
                 </a:solidFill>
               </a:rPr>
-              <a:t>Picking a Frontier Model — Q2 2026  ·  Koenig AI Academy</a:t>
+              <a:t>academy.kspl.tech | Koenig AI Academy</a:t>
             </a:r>
           </a:p>
         </p:txBody>
@@ -7230,7 +7230,7 @@
                   <a:srgbClr val="A1A1AA"/>
                 </a:solidFill>
               </a:rPr>
-              <a:t>Picking a Frontier Model — Q2 2026  ·  Koenig AI Academy</a:t>
+              <a:t>academy.kspl.tech | Koenig AI Academy</a:t>
             </a:r>
           </a:p>
         </p:txBody>
@@ -8217,7 +8217,7 @@
                   <a:srgbClr val="A1A1AA"/>
                 </a:solidFill>
               </a:rPr>
-              <a:t>Picking a Frontier Model — Q2 2026  ·  Koenig AI Academy</a:t>
+              <a:t>academy.kspl.tech | Koenig AI Academy</a:t>
             </a:r>
           </a:p>
         </p:txBody>
@@ -8762,7 +8762,7 @@
                   <a:srgbClr val="A1A1AA"/>
                 </a:solidFill>
               </a:rPr>
-              <a:t>Picking a Frontier Model — Q2 2026  ·  Koenig AI Academy</a:t>
+              <a:t>academy.kspl.tech | Koenig AI Academy</a:t>
             </a:r>
           </a:p>
         </p:txBody>

</xml_diff>